<commit_message>
feat: update patronymic to Vasilievich, add AI disclosure (Gemini) to report and presentation, update Miro board docs
</commit_message>
<xml_diff>
--- a/docs/Презентация_ПР4_Проект1_Микитенко_Ерепов.pptx
+++ b/docs/Презентация_ПР4_Проект1_Микитенко_Ерепов.pptx
@@ -14,6 +14,7 @@
     <p:sldId id="262" r:id="rId13"/>
     <p:sldId id="263" r:id="rId14"/>
     <p:sldId id="264" r:id="rId15"/>
+    <p:sldId id="265" r:id="rId16"/>
   </p:sldIdLst>
   <p:sldSz cx="12191695" cy="6858000" type="screen4x3"/>
   <p:notesSz cx="6858000" cy="9144000"/>
@@ -3209,6 +3210,171 @@
 </p:sld>
 </file>
 
+<file path=ppt/slides/slide10.xml><?xml version="1.0" encoding="utf-8"?>
+<p:sld xmlns:a="http://schemas.openxmlformats.org/drawingml/2006/main" xmlns:p="http://schemas.openxmlformats.org/presentationml/2006/main" xmlns:r="http://schemas.openxmlformats.org/officeDocument/2006/relationships">
+  <p:cSld>
+    <p:spTree>
+      <p:nvGrpSpPr>
+        <p:cNvPr id="1" name=""/>
+        <p:cNvGrpSpPr/>
+        <p:nvPr/>
+      </p:nvGrpSpPr>
+      <p:grpSpPr/>
+      <p:sp>
+        <p:nvSpPr>
+          <p:cNvPr id="2" name="TextBox 1"/>
+          <p:cNvSpPr txBox="1"/>
+          <p:nvPr/>
+        </p:nvSpPr>
+        <p:spPr>
+          <a:xfrm>
+            <a:off x="731520" y="365760"/>
+            <a:ext cx="10698480" cy="1005840"/>
+          </a:xfrm>
+          <a:prstGeom prst="rect">
+            <a:avLst/>
+          </a:prstGeom>
+          <a:noFill/>
+        </p:spPr>
+        <p:txBody>
+          <a:bodyPr wrap="square">
+            <a:spAutoFit/>
+          </a:bodyPr>
+          <a:lstStyle/>
+          <a:p>
+            <a:pPr>
+              <a:defRPr sz="1100" b="1">
+                <a:solidFill>
+                  <a:srgbClr val="2563EB"/>
+                </a:solidFill>
+              </a:defRPr>
+            </a:pPr>
+            <a:r>
+              <a:t>НИТУ МИСИС • КАФЕДРА ИКТ • ПРОЕКТ № 1</a:t>
+            </a:r>
+          </a:p>
+          <a:p>
+            <a:pPr>
+              <a:spcBef>
+                <a:spcPts val="300"/>
+              </a:spcBef>
+              <a:defRPr sz="2200" b="1">
+                <a:solidFill>
+                  <a:srgbClr val="1A2A3A"/>
+                </a:solidFill>
+              </a:defRPr>
+            </a:pPr>
+            <a:r>
+              <a:t>9. Сведения об использовании технологий искусственного интеллекта (ИИ)</a:t>
+            </a:r>
+          </a:p>
+        </p:txBody>
+      </p:sp>
+      <p:sp>
+        <p:nvSpPr>
+          <p:cNvPr id="3" name="TextBox 2"/>
+          <p:cNvSpPr txBox="1"/>
+          <p:nvPr/>
+        </p:nvSpPr>
+        <p:spPr>
+          <a:xfrm>
+            <a:off x="731520" y="1645920"/>
+            <a:ext cx="10698480" cy="4572000"/>
+          </a:xfrm>
+          <a:prstGeom prst="rect">
+            <a:avLst/>
+          </a:prstGeom>
+          <a:noFill/>
+        </p:spPr>
+        <p:txBody>
+          <a:bodyPr wrap="square">
+            <a:spAutoFit/>
+          </a:bodyPr>
+          <a:lstStyle/>
+          <a:p>
+            <a:pPr>
+              <a:defRPr sz="1400" b="1">
+                <a:solidFill>
+                  <a:srgbClr val="1A2A3A"/>
+                </a:solidFill>
+              </a:defRPr>
+            </a:pPr>
+            <a:r>
+              <a:t>Применяемый инструмент: нейросетевая модель Google Gemini (в режиме диалогового ассистента)</a:t>
+            </a:r>
+          </a:p>
+          <a:p>
+            <a:br/>
+            <a:pPr>
+              <a:defRPr sz="1300">
+                <a:solidFill>
+                  <a:srgbClr val="1A2A3A"/>
+                </a:solidFill>
+              </a:defRPr>
+            </a:pPr>
+            <a:r>
+              <a:t>🔹 Основная часть проекта (выполнена студентами группы БИВТ-26-6-9 самостоятельно):</a:t>
+            </a:r>
+            <a:br/>
+            <a:r>
+              <a:t>• Теоретический анализ стандартов IEEE 802.3, анатомии кадра и тегирования 802.1Q;</a:t>
+            </a:r>
+            <a:br/>
+            <a:r>
+              <a:t>• Ручной подбор и составление спецификации оборудования (Таблица 1);</a:t>
+            </a:r>
+            <a:br/>
+            <a:r>
+              <a:t>• Сетевое моделирование в Cisco Packet Tracer, замеры задержек и пропускной способности;</a:t>
+            </a:r>
+            <a:br/>
+            <a:r>
+              <a:t>• Разработка банка из 15 контрольных вопросов с ключами и разбором дистракторов;</a:t>
+            </a:r>
+            <a:br/>
+            <a:r>
+              <a:t>• Проектирование архитектуры виртуальной доски Miro и очная защита проекта.</a:t>
+            </a:r>
+          </a:p>
+          <a:p>
+            <a:br/>
+            <a:pPr>
+              <a:defRPr sz="1300">
+                <a:solidFill>
+                  <a:srgbClr val="64748B"/>
+                </a:solidFill>
+              </a:defRPr>
+            </a:pPr>
+            <a:r>
+              <a:t>🔹 Вспомогательная роль ИИ-ассистента:</a:t>
+            </a:r>
+            <a:br/>
+            <a:r>
+              <a:t>• Ускорение написания Python-скриптов отрисовки графиков (matplotlib/seaborn);</a:t>
+            </a:r>
+            <a:br/>
+            <a:r>
+              <a:t>• Первичный синтаксический аудит оформления библиографии по ГОСТ 7.0.100-2018;</a:t>
+            </a:r>
+            <a:br/>
+            <a:r>
+              <a:t>• Генерация чернового шаблона Google Apps Script для автоматизации создания форм.</a:t>
+            </a:r>
+            <a:br/>
+            <a:r>
+              <a:t>⚠️ Все результаты работы ИИ прошли обязательную ручную проверку и корректировку студентами.</a:t>
+            </a:r>
+          </a:p>
+        </p:txBody>
+      </p:sp>
+    </p:spTree>
+  </p:cSld>
+  <p:clrMapOvr>
+    <a:masterClrMapping/>
+  </p:clrMapOvr>
+</p:sld>
+</file>
+
 <file path=ppt/slides/slide2.xml><?xml version="1.0" encoding="utf-8"?>
 <p:sld xmlns:a="http://schemas.openxmlformats.org/drawingml/2006/main" xmlns:p="http://schemas.openxmlformats.org/presentationml/2006/main" xmlns:r="http://schemas.openxmlformats.org/officeDocument/2006/relationships">
   <p:cSld>
@@ -3487,7 +3653,7 @@
               </a:defRPr>
             </a:pPr>
             <a:r>
-              <a:t>Горбунов Константин В. — 📡 Коммуникатор (связь с командами)</a:t>
+              <a:t>Горбунов Константин Васильевич — 📡 Коммуникатор (связь с командами)</a:t>
             </a:r>
           </a:p>
           <a:p>
@@ -4297,11 +4463,11 @@
             </a:r>
             <a:br/>
             <a:r>
-              <a:t>• Виртуальная доска проекта (Miro / Notion): https://miro.com/app/board/misis-bivt-net-project1-ethernet/</a:t>
+              <a:t>• Виртуальная доска проекта (Miro): https://miro.com/app/board/uXjVEaoGUo4=/</a:t>
             </a:r>
             <a:br/>
             <a:r>
-              <a:t>• Онлайн-тестирование (Google Forms): https://forms.yandex.ru/u/misis-bivt-project1-ethernet-test/</a:t>
+              <a:t>• Онлайн-тестирование (Google Forms): https://kukes-misis.github.io/network-ethernet-project1/tests/Интерактивный_Тест_Ethernet.html</a:t>
             </a:r>
             <a:br/>
             <a:r>
@@ -4309,7 +4475,7 @@
             </a:r>
             <a:br/>
             <a:r>
-              <a:t>• Презентация и материалы защиты: https://cloud.misis.ru/s/pr4-project1-presentation-erepov/</a:t>
+              <a:t>• Веб-портал проекта: https://kukes-misis.github.io/network-ethernet-project1/</a:t>
             </a:r>
           </a:p>
         </p:txBody>

</xml_diff>

<commit_message>
refactor: completely sanitize project of Miro references and streamline academic UI for university defense
</commit_message>
<xml_diff>
--- a/docs/Презентация_ПР4_Проект1_Микитенко_Ерепов.pptx
+++ b/docs/Презентация_ПР4_Проект1_Микитенко_Ерепов.pptx
@@ -3333,7 +3333,7 @@
             </a:r>
             <a:br/>
             <a:r>
-              <a:t>• Проектирование архитектуры виртуальной доски Miro и очная защита проекта.</a:t>
+              <a:t>• Проектирование архитектуры виртуальной доски Интерактивная доска проекта и очная защита проекта.</a:t>
             </a:r>
           </a:p>
           <a:p>
@@ -3524,7 +3524,7 @@
               </a:defRPr>
             </a:pPr>
             <a:r>
-              <a:t>Проектирование визуальной доски Miro/Notion, схемы классификации L1/L2/L3 и доменов коллизий.</a:t>
+              <a:t>Проектирование визуальной доски Интерактивная доска проекта/Notion, схемы классификации L1/L2/L3 и доменов коллизий.</a:t>
             </a:r>
           </a:p>
         </p:txBody>
@@ -4463,7 +4463,7 @@
             </a:r>
             <a:br/>
             <a:r>
-              <a:t>• Виртуальная доска проекта (Miro): https://miro.com/app/board/uXjVEaoGUo4=/</a:t>
+              <a:t>• Виртуальная доска проекта (Интерактивная доска проекта): https://kukes-misis.github.io/network-ethernet-project1/</a:t>
             </a:r>
             <a:br/>
             <a:r>

</xml_diff>